<commit_message>
Snapshot of progress on ATPESC materials
</commit_message>
<xml_diff>
--- a/license-master.pptx
+++ b/license-master.pptx
@@ -255,7 +255,7 @@
           <a:p>
             <a:fld id="{0B842F42-2CE9-4E35-95C1-410DC08A50B1}" type="datetimeFigureOut">
               <a:rPr lang="en-US" smtClean="0"/>
-              <a:t>7/26/2024</a:t>
+              <a:t>8/3/2025</a:t>
             </a:fld>
             <a:endParaRPr lang="en-US"/>
           </a:p>
@@ -420,7 +420,7 @@
           <a:p>
             <a:fld id="{6F282904-F315-4730-8D91-37D99E141A6F}" type="datetimeFigureOut">
               <a:rPr lang="en-US" smtClean="0"/>
-              <a:t>7/26/2024</a:t>
+              <a:t>8/3/2025</a:t>
             </a:fld>
             <a:endParaRPr lang="en-US"/>
           </a:p>
@@ -4089,13 +4089,13 @@
             </a:r>
             <a:r>
               <a:rPr lang="en-US" sz="1600" dirty="0"/>
-              <a:t>Anshu Dubey, David E. Bernholdt, Todd Gamblin, and Jared O’Neal, Software Productivity and Sustainability track, in Argonne Training Program on Extreme-Scale Computing, St. Charles, Illinois, 2024. DOI: </a:t>
+              <a:t>Anshu Dubey, David E. Bernholdt, and Todd Gamblin, Software Sustainability track, in Argonne Training Program on Extreme-Scale Computing, St. Charles, Illinois, 2025. DOI: </a:t>
             </a:r>
             <a:r>
               <a:rPr lang="en-US" sz="1600" dirty="0">
                 <a:hlinkClick r:id="rId4"/>
               </a:rPr>
-              <a:t>10.6084/m9.figshare.26384188</a:t>
+              <a:t>10.6084/m9.figshare.29816981</a:t>
             </a:r>
             <a:r>
               <a:rPr lang="en-US" sz="1600" dirty="0"/>
@@ -5213,21 +5213,6 @@
 </file>
 
 <file path=customXml/item1.xml><?xml version="1.0" encoding="utf-8"?>
-<?mso-contentType ?>
-<FormTemplates xmlns="http://schemas.microsoft.com/sharepoint/v3/contenttype/forms">
-  <Display>DocumentLibraryForm</Display>
-  <Edit>DocumentLibraryForm</Edit>
-  <New>DocumentLibraryForm</New>
-</FormTemplates>
-</file>
-
-<file path=customXml/item2.xml><?xml version="1.0" encoding="utf-8"?>
-<p:properties xmlns:p="http://schemas.microsoft.com/office/2006/metadata/properties" xmlns:xsi="http://www.w3.org/2001/XMLSchema-instance" xmlns:pc="http://schemas.microsoft.com/office/infopath/2007/PartnerControls">
-  <documentManagement/>
-</p:properties>
-</file>
-
-<file path=customXml/item3.xml><?xml version="1.0" encoding="utf-8"?>
 <ct:contentTypeSchema xmlns:ct="http://schemas.microsoft.com/office/2006/metadata/contentType" xmlns:ma="http://schemas.microsoft.com/office/2006/metadata/properties/metaAttributes" ct:_="" ma:_="" ma:contentTypeName="Document" ma:contentTypeID="0x010100565464437F680748A68B85EB6594EA7D" ma:contentTypeVersion="0" ma:contentTypeDescription="Create a new document." ma:contentTypeScope="" ma:versionID="fe3f4dd58d5914c51cfc6deaa8ad845c">
   <xsd:schema xmlns:xsd="http://www.w3.org/2001/XMLSchema" xmlns:p="http://schemas.microsoft.com/office/2006/metadata/properties" targetNamespace="http://schemas.microsoft.com/office/2006/metadata/properties" ma:root="true" ma:fieldsID="4aeb20c0e3442673af7ee10786458764">
     <xsd:element name="properties">
@@ -5276,10 +5261,32 @@
 </ct:contentTypeSchema>
 </file>
 
+<file path=customXml/item2.xml><?xml version="1.0" encoding="utf-8"?>
+<p:properties xmlns:p="http://schemas.microsoft.com/office/2006/metadata/properties" xmlns:xsi="http://www.w3.org/2001/XMLSchema-instance" xmlns:pc="http://schemas.microsoft.com/office/infopath/2007/PartnerControls">
+  <documentManagement/>
+</p:properties>
+</file>
+
+<file path=customXml/item3.xml><?xml version="1.0" encoding="utf-8"?>
+<?mso-contentType ?>
+<FormTemplates xmlns="http://schemas.microsoft.com/sharepoint/v3/contenttype/forms">
+  <Display>DocumentLibraryForm</Display>
+  <Edit>DocumentLibraryForm</Edit>
+  <New>DocumentLibraryForm</New>
+</FormTemplates>
+</file>
+
 <file path=customXml/itemProps1.xml><?xml version="1.0" encoding="utf-8"?>
-<ds:datastoreItem xmlns:ds="http://schemas.openxmlformats.org/officeDocument/2006/customXml" ds:itemID="{19E20559-B232-4371-8690-E3D8007EDB82}">
+<ds:datastoreItem xmlns:ds="http://schemas.openxmlformats.org/officeDocument/2006/customXml" ds:itemID="{E8DB7DEB-074E-4EE8-9B6E-FD277323109C}">
   <ds:schemaRefs>
-    <ds:schemaRef ds:uri="http://schemas.microsoft.com/sharepoint/v3/contenttype/forms"/>
+    <ds:schemaRef ds:uri="http://schemas.microsoft.com/office/2006/metadata/contentType"/>
+    <ds:schemaRef ds:uri="http://schemas.microsoft.com/office/2006/metadata/properties/metaAttributes"/>
+    <ds:schemaRef ds:uri="http://www.w3.org/2001/XMLSchema"/>
+    <ds:schemaRef ds:uri="http://schemas.microsoft.com/office/2006/metadata/properties"/>
+    <ds:schemaRef ds:uri="http://schemas.openxmlformats.org/package/2006/metadata/core-properties"/>
+    <ds:schemaRef ds:uri="http://purl.org/dc/elements/1.1/"/>
+    <ds:schemaRef ds:uri="http://purl.org/dc/terms/"/>
+    <ds:schemaRef ds:uri="http://schemas.microsoft.com/office/internal/2005/internalDocumentation"/>
   </ds:schemaRefs>
 </ds:datastoreItem>
 </file>
@@ -5300,16 +5307,9 @@
 </file>
 
 <file path=customXml/itemProps3.xml><?xml version="1.0" encoding="utf-8"?>
-<ds:datastoreItem xmlns:ds="http://schemas.openxmlformats.org/officeDocument/2006/customXml" ds:itemID="{E8DB7DEB-074E-4EE8-9B6E-FD277323109C}">
+<ds:datastoreItem xmlns:ds="http://schemas.openxmlformats.org/officeDocument/2006/customXml" ds:itemID="{19E20559-B232-4371-8690-E3D8007EDB82}">
   <ds:schemaRefs>
-    <ds:schemaRef ds:uri="http://schemas.microsoft.com/office/2006/metadata/contentType"/>
-    <ds:schemaRef ds:uri="http://schemas.microsoft.com/office/2006/metadata/properties/metaAttributes"/>
-    <ds:schemaRef ds:uri="http://www.w3.org/2001/XMLSchema"/>
-    <ds:schemaRef ds:uri="http://schemas.microsoft.com/office/2006/metadata/properties"/>
-    <ds:schemaRef ds:uri="http://schemas.openxmlformats.org/package/2006/metadata/core-properties"/>
-    <ds:schemaRef ds:uri="http://purl.org/dc/elements/1.1/"/>
-    <ds:schemaRef ds:uri="http://purl.org/dc/terms/"/>
-    <ds:schemaRef ds:uri="http://schemas.microsoft.com/office/internal/2005/internalDocumentation"/>
+    <ds:schemaRef ds:uri="http://schemas.microsoft.com/sharepoint/v3/contenttype/forms"/>
   </ds:schemaRefs>
 </ds:datastoreItem>
 </file>
</xml_diff>

<commit_message>
Capture reserved DOI and update License slide
</commit_message>
<xml_diff>
--- a/license-master.pptx
+++ b/license-master.pptx
@@ -255,7 +255,7 @@
           <a:p>
             <a:fld id="{0B842F42-2CE9-4E35-95C1-410DC08A50B1}" type="datetimeFigureOut">
               <a:rPr lang="en-US" smtClean="0"/>
-              <a:t>8/3/2025</a:t>
+              <a:t>10/19/2025</a:t>
             </a:fld>
             <a:endParaRPr lang="en-US"/>
           </a:p>
@@ -420,7 +420,7 @@
           <a:p>
             <a:fld id="{6F282904-F315-4730-8D91-37D99E141A6F}" type="datetimeFigureOut">
               <a:rPr lang="en-US" smtClean="0"/>
-              <a:t>8/3/2025</a:t>
+              <a:t>10/19/2025</a:t>
             </a:fld>
             <a:endParaRPr lang="en-US"/>
           </a:p>
@@ -4001,7 +4001,7 @@
         </p:nvSpPr>
         <p:spPr>
           <a:xfrm>
-            <a:off x="363096" y="112911"/>
+            <a:off x="363096" y="411282"/>
             <a:ext cx="11372473" cy="914400"/>
           </a:xfrm>
         </p:spPr>
@@ -4034,7 +4034,7 @@
         </p:nvSpPr>
         <p:spPr>
           <a:xfrm>
-            <a:off x="409507" y="570111"/>
+            <a:off x="409507" y="868482"/>
             <a:ext cx="11369809" cy="4047778"/>
           </a:xfrm>
         </p:spPr>
@@ -4089,13 +4089,13 @@
             </a:r>
             <a:r>
               <a:rPr lang="en-US" sz="1600" dirty="0"/>
-              <a:t>Anshu Dubey, David E. Bernholdt, and Todd Gamblin, Software Sustainability track, in Argonne Training Program on Extreme-Scale Computing, St. Charles, Illinois, 2025. DOI: </a:t>
+              <a:t>David E. Bernholdt and Anshu Dubey, Better Software for Reproducible Science tutorial, in The International Conference for High-Performance Computing, Networking, Storage, and Analysis (SC25), St. Louis, Missouri, 2025. DOI: </a:t>
             </a:r>
             <a:r>
               <a:rPr lang="en-US" sz="1600" dirty="0">
                 <a:hlinkClick r:id="rId4"/>
               </a:rPr>
-              <a:t>10.6084/m9.figshare.29816981</a:t>
+              <a:t>10.6084/m9.figshare.30394186</a:t>
             </a:r>
             <a:r>
               <a:rPr lang="en-US" sz="1600" dirty="0"/>
@@ -5213,6 +5213,21 @@
 </file>
 
 <file path=customXml/item1.xml><?xml version="1.0" encoding="utf-8"?>
+<?mso-contentType ?>
+<FormTemplates xmlns="http://schemas.microsoft.com/sharepoint/v3/contenttype/forms">
+  <Display>DocumentLibraryForm</Display>
+  <Edit>DocumentLibraryForm</Edit>
+  <New>DocumentLibraryForm</New>
+</FormTemplates>
+</file>
+
+<file path=customXml/item2.xml><?xml version="1.0" encoding="utf-8"?>
+<p:properties xmlns:p="http://schemas.microsoft.com/office/2006/metadata/properties" xmlns:xsi="http://www.w3.org/2001/XMLSchema-instance" xmlns:pc="http://schemas.microsoft.com/office/infopath/2007/PartnerControls">
+  <documentManagement/>
+</p:properties>
+</file>
+
+<file path=customXml/item3.xml><?xml version="1.0" encoding="utf-8"?>
 <ct:contentTypeSchema xmlns:ct="http://schemas.microsoft.com/office/2006/metadata/contentType" xmlns:ma="http://schemas.microsoft.com/office/2006/metadata/properties/metaAttributes" ct:_="" ma:_="" ma:contentTypeName="Document" ma:contentTypeID="0x010100565464437F680748A68B85EB6594EA7D" ma:contentTypeVersion="0" ma:contentTypeDescription="Create a new document." ma:contentTypeScope="" ma:versionID="fe3f4dd58d5914c51cfc6deaa8ad845c">
   <xsd:schema xmlns:xsd="http://www.w3.org/2001/XMLSchema" xmlns:p="http://schemas.microsoft.com/office/2006/metadata/properties" targetNamespace="http://schemas.microsoft.com/office/2006/metadata/properties" ma:root="true" ma:fieldsID="4aeb20c0e3442673af7ee10786458764">
     <xsd:element name="properties">
@@ -5261,32 +5276,10 @@
 </ct:contentTypeSchema>
 </file>
 
-<file path=customXml/item2.xml><?xml version="1.0" encoding="utf-8"?>
-<p:properties xmlns:p="http://schemas.microsoft.com/office/2006/metadata/properties" xmlns:xsi="http://www.w3.org/2001/XMLSchema-instance" xmlns:pc="http://schemas.microsoft.com/office/infopath/2007/PartnerControls">
-  <documentManagement/>
-</p:properties>
-</file>
-
-<file path=customXml/item3.xml><?xml version="1.0" encoding="utf-8"?>
-<?mso-contentType ?>
-<FormTemplates xmlns="http://schemas.microsoft.com/sharepoint/v3/contenttype/forms">
-  <Display>DocumentLibraryForm</Display>
-  <Edit>DocumentLibraryForm</Edit>
-  <New>DocumentLibraryForm</New>
-</FormTemplates>
-</file>
-
 <file path=customXml/itemProps1.xml><?xml version="1.0" encoding="utf-8"?>
-<ds:datastoreItem xmlns:ds="http://schemas.openxmlformats.org/officeDocument/2006/customXml" ds:itemID="{E8DB7DEB-074E-4EE8-9B6E-FD277323109C}">
+<ds:datastoreItem xmlns:ds="http://schemas.openxmlformats.org/officeDocument/2006/customXml" ds:itemID="{19E20559-B232-4371-8690-E3D8007EDB82}">
   <ds:schemaRefs>
-    <ds:schemaRef ds:uri="http://schemas.microsoft.com/office/2006/metadata/contentType"/>
-    <ds:schemaRef ds:uri="http://schemas.microsoft.com/office/2006/metadata/properties/metaAttributes"/>
-    <ds:schemaRef ds:uri="http://www.w3.org/2001/XMLSchema"/>
-    <ds:schemaRef ds:uri="http://schemas.microsoft.com/office/2006/metadata/properties"/>
-    <ds:schemaRef ds:uri="http://schemas.openxmlformats.org/package/2006/metadata/core-properties"/>
-    <ds:schemaRef ds:uri="http://purl.org/dc/elements/1.1/"/>
-    <ds:schemaRef ds:uri="http://purl.org/dc/terms/"/>
-    <ds:schemaRef ds:uri="http://schemas.microsoft.com/office/internal/2005/internalDocumentation"/>
+    <ds:schemaRef ds:uri="http://schemas.microsoft.com/sharepoint/v3/contenttype/forms"/>
   </ds:schemaRefs>
 </ds:datastoreItem>
 </file>
@@ -5307,9 +5300,16 @@
 </file>
 
 <file path=customXml/itemProps3.xml><?xml version="1.0" encoding="utf-8"?>
-<ds:datastoreItem xmlns:ds="http://schemas.openxmlformats.org/officeDocument/2006/customXml" ds:itemID="{19E20559-B232-4371-8690-E3D8007EDB82}">
+<ds:datastoreItem xmlns:ds="http://schemas.openxmlformats.org/officeDocument/2006/customXml" ds:itemID="{E8DB7DEB-074E-4EE8-9B6E-FD277323109C}">
   <ds:schemaRefs>
-    <ds:schemaRef ds:uri="http://schemas.microsoft.com/sharepoint/v3/contenttype/forms"/>
+    <ds:schemaRef ds:uri="http://schemas.microsoft.com/office/2006/metadata/contentType"/>
+    <ds:schemaRef ds:uri="http://schemas.microsoft.com/office/2006/metadata/properties/metaAttributes"/>
+    <ds:schemaRef ds:uri="http://www.w3.org/2001/XMLSchema"/>
+    <ds:schemaRef ds:uri="http://schemas.microsoft.com/office/2006/metadata/properties"/>
+    <ds:schemaRef ds:uri="http://schemas.openxmlformats.org/package/2006/metadata/core-properties"/>
+    <ds:schemaRef ds:uri="http://purl.org/dc/elements/1.1/"/>
+    <ds:schemaRef ds:uri="http://purl.org/dc/terms/"/>
+    <ds:schemaRef ds:uri="http://schemas.microsoft.com/office/internal/2005/internalDocumentation"/>
   </ds:schemaRefs>
 </ds:datastoreItem>
 </file>
</xml_diff>

<commit_message>
More appropriate funding credit
Added SciDAC
</commit_message>
<xml_diff>
--- a/license-master.pptx
+++ b/license-master.pptx
@@ -255,7 +255,7 @@
           <a:p>
             <a:fld id="{0B842F42-2CE9-4E35-95C1-410DC08A50B1}" type="datetimeFigureOut">
               <a:rPr lang="en-US" smtClean="0"/>
-              <a:t>10/19/2025</a:t>
+              <a:t>10/25/2025</a:t>
             </a:fld>
             <a:endParaRPr lang="en-US"/>
           </a:p>
@@ -420,7 +420,7 @@
           <a:p>
             <a:fld id="{6F282904-F315-4730-8D91-37D99E141A6F}" type="datetimeFigureOut">
               <a:rPr lang="en-US" smtClean="0"/>
-              <a:t>10/19/2025</a:t>
+              <a:t>10/25/2025</a:t>
             </a:fld>
             <a:endParaRPr lang="en-US"/>
           </a:p>
@@ -4162,10 +4162,18 @@
             </a:pPr>
             <a:r>
               <a:rPr lang="en-US" sz="1400" dirty="0"/>
-              <a:t>This work was supported by the U.S. Department of Energy Office of Science, Office of Advanced Scientific Computing Research (ASCR), and by the Exascale Computing Project (17-SC-20-SC), a collaborative effort of the U.S. Department of Energy Office of Science and the National Nuclear Security Administration</a:t>
-            </a:r>
-            <a:r>
-              <a:rPr lang="en-US" sz="1400" i="1" dirty="0"/>
+              <a:t>This work was supported by the U.S. Department of Energy, Office of Science, Office of Advanced Scientific Computing Research, Next-Generation Scientific Software Technologies (NGSST) and Scientific Discovery through Advanced Computing (</a:t>
+            </a:r>
+            <a:r>
+              <a:rPr lang="en-US" sz="1400" dirty="0" err="1"/>
+              <a:t>SciDAC</a:t>
+            </a:r>
+            <a:r>
+              <a:rPr lang="en-US" sz="1400"/>
+              <a:t>) programs</a:t>
+            </a:r>
+            <a:r>
+              <a:rPr lang="en-US" sz="1400" dirty="0"/>
               <a:t>.</a:t>
             </a:r>
           </a:p>
@@ -4176,11 +4184,12 @@
               </a:spcBef>
             </a:pPr>
             <a:r>
-              <a:rPr lang="en-US" sz="1400" b="0" i="0" dirty="0">
-                <a:effectLst/>
-                <a:latin typeface="+mn-lt"/>
-              </a:rPr>
-              <a:t>This work was supported by the U.S. Department of Energy, Office of Science, Office of Advanced Scientific Computing Research, Next-Generation Scientific Software Technologies (NGSST) program.</a:t>
+              <a:rPr lang="en-US" sz="1400" dirty="0"/>
+              <a:t>This work was supported by the U.S. Department of Energy Office of Science, Office of Advanced Scientific Computing Research (ASCR), and by the Exascale Computing Project (17-SC-20-SC), a collaborative effort of the U.S. Department of Energy Office of Science and the National Nuclear Security Administration</a:t>
+            </a:r>
+            <a:r>
+              <a:rPr lang="en-US" sz="1400" i="1" dirty="0"/>
+              <a:t>.</a:t>
             </a:r>
           </a:p>
           <a:p>
@@ -5213,21 +5222,6 @@
 </file>
 
 <file path=customXml/item1.xml><?xml version="1.0" encoding="utf-8"?>
-<?mso-contentType ?>
-<FormTemplates xmlns="http://schemas.microsoft.com/sharepoint/v3/contenttype/forms">
-  <Display>DocumentLibraryForm</Display>
-  <Edit>DocumentLibraryForm</Edit>
-  <New>DocumentLibraryForm</New>
-</FormTemplates>
-</file>
-
-<file path=customXml/item2.xml><?xml version="1.0" encoding="utf-8"?>
-<p:properties xmlns:p="http://schemas.microsoft.com/office/2006/metadata/properties" xmlns:xsi="http://www.w3.org/2001/XMLSchema-instance" xmlns:pc="http://schemas.microsoft.com/office/infopath/2007/PartnerControls">
-  <documentManagement/>
-</p:properties>
-</file>
-
-<file path=customXml/item3.xml><?xml version="1.0" encoding="utf-8"?>
 <ct:contentTypeSchema xmlns:ct="http://schemas.microsoft.com/office/2006/metadata/contentType" xmlns:ma="http://schemas.microsoft.com/office/2006/metadata/properties/metaAttributes" ct:_="" ma:_="" ma:contentTypeName="Document" ma:contentTypeID="0x010100565464437F680748A68B85EB6594EA7D" ma:contentTypeVersion="0" ma:contentTypeDescription="Create a new document." ma:contentTypeScope="" ma:versionID="fe3f4dd58d5914c51cfc6deaa8ad845c">
   <xsd:schema xmlns:xsd="http://www.w3.org/2001/XMLSchema" xmlns:p="http://schemas.microsoft.com/office/2006/metadata/properties" targetNamespace="http://schemas.microsoft.com/office/2006/metadata/properties" ma:root="true" ma:fieldsID="4aeb20c0e3442673af7ee10786458764">
     <xsd:element name="properties">
@@ -5276,10 +5270,32 @@
 </ct:contentTypeSchema>
 </file>
 
+<file path=customXml/item2.xml><?xml version="1.0" encoding="utf-8"?>
+<p:properties xmlns:p="http://schemas.microsoft.com/office/2006/metadata/properties" xmlns:xsi="http://www.w3.org/2001/XMLSchema-instance" xmlns:pc="http://schemas.microsoft.com/office/infopath/2007/PartnerControls">
+  <documentManagement/>
+</p:properties>
+</file>
+
+<file path=customXml/item3.xml><?xml version="1.0" encoding="utf-8"?>
+<?mso-contentType ?>
+<FormTemplates xmlns="http://schemas.microsoft.com/sharepoint/v3/contenttype/forms">
+  <Display>DocumentLibraryForm</Display>
+  <Edit>DocumentLibraryForm</Edit>
+  <New>DocumentLibraryForm</New>
+</FormTemplates>
+</file>
+
 <file path=customXml/itemProps1.xml><?xml version="1.0" encoding="utf-8"?>
-<ds:datastoreItem xmlns:ds="http://schemas.openxmlformats.org/officeDocument/2006/customXml" ds:itemID="{19E20559-B232-4371-8690-E3D8007EDB82}">
+<ds:datastoreItem xmlns:ds="http://schemas.openxmlformats.org/officeDocument/2006/customXml" ds:itemID="{E8DB7DEB-074E-4EE8-9B6E-FD277323109C}">
   <ds:schemaRefs>
-    <ds:schemaRef ds:uri="http://schemas.microsoft.com/sharepoint/v3/contenttype/forms"/>
+    <ds:schemaRef ds:uri="http://schemas.microsoft.com/office/2006/metadata/contentType"/>
+    <ds:schemaRef ds:uri="http://schemas.microsoft.com/office/2006/metadata/properties/metaAttributes"/>
+    <ds:schemaRef ds:uri="http://www.w3.org/2001/XMLSchema"/>
+    <ds:schemaRef ds:uri="http://schemas.microsoft.com/office/2006/metadata/properties"/>
+    <ds:schemaRef ds:uri="http://schemas.openxmlformats.org/package/2006/metadata/core-properties"/>
+    <ds:schemaRef ds:uri="http://purl.org/dc/elements/1.1/"/>
+    <ds:schemaRef ds:uri="http://purl.org/dc/terms/"/>
+    <ds:schemaRef ds:uri="http://schemas.microsoft.com/office/internal/2005/internalDocumentation"/>
   </ds:schemaRefs>
 </ds:datastoreItem>
 </file>
@@ -5300,16 +5316,9 @@
 </file>
 
 <file path=customXml/itemProps3.xml><?xml version="1.0" encoding="utf-8"?>
-<ds:datastoreItem xmlns:ds="http://schemas.openxmlformats.org/officeDocument/2006/customXml" ds:itemID="{E8DB7DEB-074E-4EE8-9B6E-FD277323109C}">
+<ds:datastoreItem xmlns:ds="http://schemas.openxmlformats.org/officeDocument/2006/customXml" ds:itemID="{19E20559-B232-4371-8690-E3D8007EDB82}">
   <ds:schemaRefs>
-    <ds:schemaRef ds:uri="http://schemas.microsoft.com/office/2006/metadata/contentType"/>
-    <ds:schemaRef ds:uri="http://schemas.microsoft.com/office/2006/metadata/properties/metaAttributes"/>
-    <ds:schemaRef ds:uri="http://www.w3.org/2001/XMLSchema"/>
-    <ds:schemaRef ds:uri="http://schemas.microsoft.com/office/2006/metadata/properties"/>
-    <ds:schemaRef ds:uri="http://schemas.openxmlformats.org/package/2006/metadata/core-properties"/>
-    <ds:schemaRef ds:uri="http://purl.org/dc/elements/1.1/"/>
-    <ds:schemaRef ds:uri="http://purl.org/dc/terms/"/>
-    <ds:schemaRef ds:uri="http://schemas.microsoft.com/office/internal/2005/internalDocumentation"/>
+    <ds:schemaRef ds:uri="http://schemas.microsoft.com/sharepoint/v3/contenttype/forms"/>
   </ds:schemaRefs>
 </ds:datastoreItem>
 </file>
</xml_diff>

<commit_message>
Update license-master for ATPESC 2026
</commit_message>
<xml_diff>
--- a/license-master.pptx
+++ b/license-master.pptx
@@ -255,7 +255,7 @@
           <a:p>
             <a:fld id="{0B842F42-2CE9-4E35-95C1-410DC08A50B1}" type="datetimeFigureOut">
               <a:rPr lang="en-US" smtClean="0"/>
-              <a:t>1/22/2026</a:t>
+              <a:t>8/2/2026</a:t>
             </a:fld>
             <a:endParaRPr lang="en-US"/>
           </a:p>
@@ -420,7 +420,7 @@
           <a:p>
             <a:fld id="{6F282904-F315-4730-8D91-37D99E141A6F}" type="datetimeFigureOut">
               <a:rPr lang="en-US" smtClean="0"/>
-              <a:t>1/22/2026</a:t>
+              <a:t>8/2/2026</a:t>
             </a:fld>
             <a:endParaRPr lang="en-US"/>
           </a:p>
@@ -4089,29 +4089,13 @@
             </a:r>
             <a:r>
               <a:rPr lang="en-US" sz="1600" dirty="0"/>
-              <a:t>Anshu Dubey and Akash Dhruv, Better Software for Science with High-Performance Computing tutorial, in </a:t>
-            </a:r>
-            <a:r>
-              <a:rPr lang="en-US" sz="1600" dirty="0" err="1"/>
-              <a:t>SupercomputingAsia</a:t>
-            </a:r>
-            <a:r>
-              <a:rPr lang="en-US" sz="1600" dirty="0"/>
-              <a:t> 2026 (SCA 2026)/The International Conference on High Performance Computing in Asia-Pacific Region 2026 (</a:t>
-            </a:r>
-            <a:r>
-              <a:rPr lang="en-US" sz="1600" dirty="0" err="1"/>
-              <a:t>HPCAsia</a:t>
-            </a:r>
-            <a:r>
-              <a:rPr lang="en-US" sz="1600" dirty="0"/>
-              <a:t> 2026), Osaka, Japan, 2026. DOI: </a:t>
+              <a:t>David E. Bernholdt, Software Sustainability track, in Argonne Training Program on Extreme-Scale Computing, St. Charles, Illinois, 2026. DOI: </a:t>
             </a:r>
             <a:r>
               <a:rPr lang="en-US" sz="1600" dirty="0">
                 <a:hlinkClick r:id="rId4"/>
               </a:rPr>
-              <a:t>10.6084/m9.figshare.31130062</a:t>
+              <a:t>10.6084/m9.figshare.33139910</a:t>
             </a:r>
             <a:r>
               <a:rPr lang="en-US" sz="1600" dirty="0"/>
@@ -5234,21 +5218,6 @@
 </file>
 
 <file path=customXml/item1.xml><?xml version="1.0" encoding="utf-8"?>
-<?mso-contentType ?>
-<FormTemplates xmlns="http://schemas.microsoft.com/sharepoint/v3/contenttype/forms">
-  <Display>DocumentLibraryForm</Display>
-  <Edit>DocumentLibraryForm</Edit>
-  <New>DocumentLibraryForm</New>
-</FormTemplates>
-</file>
-
-<file path=customXml/item2.xml><?xml version="1.0" encoding="utf-8"?>
-<p:properties xmlns:p="http://schemas.microsoft.com/office/2006/metadata/properties" xmlns:xsi="http://www.w3.org/2001/XMLSchema-instance" xmlns:pc="http://schemas.microsoft.com/office/infopath/2007/PartnerControls">
-  <documentManagement/>
-</p:properties>
-</file>
-
-<file path=customXml/item3.xml><?xml version="1.0" encoding="utf-8"?>
 <ct:contentTypeSchema xmlns:ct="http://schemas.microsoft.com/office/2006/metadata/contentType" xmlns:ma="http://schemas.microsoft.com/office/2006/metadata/properties/metaAttributes" ct:_="" ma:_="" ma:contentTypeName="Document" ma:contentTypeID="0x010100565464437F680748A68B85EB6594EA7D" ma:contentTypeVersion="0" ma:contentTypeDescription="Create a new document." ma:contentTypeScope="" ma:versionID="fe3f4dd58d5914c51cfc6deaa8ad845c">
   <xsd:schema xmlns:xsd="http://www.w3.org/2001/XMLSchema" xmlns:p="http://schemas.microsoft.com/office/2006/metadata/properties" targetNamespace="http://schemas.microsoft.com/office/2006/metadata/properties" ma:root="true" ma:fieldsID="4aeb20c0e3442673af7ee10786458764">
     <xsd:element name="properties">
@@ -5297,10 +5266,32 @@
 </ct:contentTypeSchema>
 </file>
 
+<file path=customXml/item2.xml><?xml version="1.0" encoding="utf-8"?>
+<p:properties xmlns:p="http://schemas.microsoft.com/office/2006/metadata/properties" xmlns:xsi="http://www.w3.org/2001/XMLSchema-instance" xmlns:pc="http://schemas.microsoft.com/office/infopath/2007/PartnerControls">
+  <documentManagement/>
+</p:properties>
+</file>
+
+<file path=customXml/item3.xml><?xml version="1.0" encoding="utf-8"?>
+<?mso-contentType ?>
+<FormTemplates xmlns="http://schemas.microsoft.com/sharepoint/v3/contenttype/forms">
+  <Display>DocumentLibraryForm</Display>
+  <Edit>DocumentLibraryForm</Edit>
+  <New>DocumentLibraryForm</New>
+</FormTemplates>
+</file>
+
 <file path=customXml/itemProps1.xml><?xml version="1.0" encoding="utf-8"?>
-<ds:datastoreItem xmlns:ds="http://schemas.openxmlformats.org/officeDocument/2006/customXml" ds:itemID="{19E20559-B232-4371-8690-E3D8007EDB82}">
+<ds:datastoreItem xmlns:ds="http://schemas.openxmlformats.org/officeDocument/2006/customXml" ds:itemID="{E8DB7DEB-074E-4EE8-9B6E-FD277323109C}">
   <ds:schemaRefs>
-    <ds:schemaRef ds:uri="http://schemas.microsoft.com/sharepoint/v3/contenttype/forms"/>
+    <ds:schemaRef ds:uri="http://schemas.microsoft.com/office/2006/metadata/contentType"/>
+    <ds:schemaRef ds:uri="http://schemas.microsoft.com/office/2006/metadata/properties/metaAttributes"/>
+    <ds:schemaRef ds:uri="http://www.w3.org/2001/XMLSchema"/>
+    <ds:schemaRef ds:uri="http://schemas.microsoft.com/office/2006/metadata/properties"/>
+    <ds:schemaRef ds:uri="http://schemas.openxmlformats.org/package/2006/metadata/core-properties"/>
+    <ds:schemaRef ds:uri="http://purl.org/dc/elements/1.1/"/>
+    <ds:schemaRef ds:uri="http://purl.org/dc/terms/"/>
+    <ds:schemaRef ds:uri="http://schemas.microsoft.com/office/internal/2005/internalDocumentation"/>
   </ds:schemaRefs>
 </ds:datastoreItem>
 </file>
@@ -5321,16 +5312,9 @@
 </file>
 
 <file path=customXml/itemProps3.xml><?xml version="1.0" encoding="utf-8"?>
-<ds:datastoreItem xmlns:ds="http://schemas.openxmlformats.org/officeDocument/2006/customXml" ds:itemID="{E8DB7DEB-074E-4EE8-9B6E-FD277323109C}">
+<ds:datastoreItem xmlns:ds="http://schemas.openxmlformats.org/officeDocument/2006/customXml" ds:itemID="{19E20559-B232-4371-8690-E3D8007EDB82}">
   <ds:schemaRefs>
-    <ds:schemaRef ds:uri="http://schemas.microsoft.com/office/2006/metadata/contentType"/>
-    <ds:schemaRef ds:uri="http://schemas.microsoft.com/office/2006/metadata/properties/metaAttributes"/>
-    <ds:schemaRef ds:uri="http://www.w3.org/2001/XMLSchema"/>
-    <ds:schemaRef ds:uri="http://schemas.microsoft.com/office/2006/metadata/properties"/>
-    <ds:schemaRef ds:uri="http://schemas.openxmlformats.org/package/2006/metadata/core-properties"/>
-    <ds:schemaRef ds:uri="http://purl.org/dc/elements/1.1/"/>
-    <ds:schemaRef ds:uri="http://purl.org/dc/terms/"/>
-    <ds:schemaRef ds:uri="http://schemas.microsoft.com/office/internal/2005/internalDocumentation"/>
+    <ds:schemaRef ds:uri="http://schemas.microsoft.com/sharepoint/v3/contenttype/forms"/>
   </ds:schemaRefs>
 </ds:datastoreItem>
 </file>
</xml_diff>